<commit_message>
Publish the dashboard and hand judges the direct links
The read-only dashboard existed only as source, so reading the README meant
installing Node before seeing anything run. Publish ui/dist to GitHub Pages on
every push to main and put the resulting address at the top of the dashboard
section, where a reviewer sees it before any instruction to install something.
The workflow needs no secret: the dashboard makes public view calls from the
visitor's browser and has no wallet, signer or backend.

Replace the deck's external-link arrow with a character that has no emoji
presentation. The previous glyph fell back to a color emoji font in PDF
conversion and rendered as a pale blue tile on a black slide. Ship the PDF
alongside the PowerPoint file so the deck can be read without an Office
application.
</commit_message>
<xml_diff>
--- a/assets/Cr3dX_RWA_Deck_v1.pptx
+++ b/assets/Cr3dX_RWA_Deck_v1.pptx
@@ -3549,7 +3549,7 @@
                 <a:cs typeface="Arial"/>
                 <a:hlinkClick xmlns:r="http://schemas.openxmlformats.org/officeDocument/2006/relationships" r:id="R0478b1120a2448dd"/>
               </a:rPr>
-              <a:t>Repository ↗</a:t>
+              <a:t>Repository »</a:t>
             </a:r>
             <a:r>
               <a:rPr sz="1350" b="0" u="none">
@@ -3572,7 +3572,7 @@
                 <a:cs typeface="Arial"/>
                 <a:hlinkClick xmlns:r="http://schemas.openxmlformats.org/officeDocument/2006/relationships" r:id="Rbb113e3cecb04702"/>
               </a:rPr>
-              <a:t>Live dashboard ↗</a:t>
+              <a:t>Live dashboard »</a:t>
             </a:r>
             <a:endParaRPr sz="1350" b="0" u="none">
               <a:solidFill>
@@ -6377,7 +6377,7 @@
                 <a:cs typeface="Arial"/>
                 <a:hlinkClick xmlns:r="http://schemas.openxmlformats.org/officeDocument/2006/relationships" r:id="R651bae81764a4f23"/>
               </a:rPr>
-              <a:t>Live dashboard ↗</a:t>
+              <a:t>Live dashboard »</a:t>
             </a:r>
             <a:r>
               <a:rPr sz="1280" b="0" u="none">
@@ -6400,7 +6400,7 @@
                 <a:cs typeface="Arial"/>
                 <a:hlinkClick xmlns:r="http://schemas.openxmlformats.org/officeDocument/2006/relationships" r:id="Rf60d481bf79d48e5"/>
               </a:rPr>
-              <a:t>Repository ↗</a:t>
+              <a:t>Repository »</a:t>
             </a:r>
             <a:r>
               <a:rPr sz="1280" b="0" u="none">
@@ -6423,7 +6423,7 @@
                 <a:cs typeface="Arial"/>
                 <a:hlinkClick xmlns:r="http://schemas.openxmlformats.org/officeDocument/2006/relationships" r:id="R79b87ce370594a16"/>
               </a:rPr>
-              <a:t>Phase B manifests ↗</a:t>
+              <a:t>Phase B manifests »</a:t>
             </a:r>
             <a:endParaRPr sz="1280" b="0" u="none">
               <a:solidFill>
@@ -6544,7 +6544,7 @@
                 <a:cs typeface="Arial"/>
                 <a:hlinkClick xmlns:r="http://schemas.openxmlformats.org/officeDocument/2006/relationships" r:id="R9237434f52b14aaa"/>
               </a:rPr>
-              <a:t>S5 live runbook ↗</a:t>
+              <a:t>S5 live runbook »</a:t>
             </a:r>
             <a:r>
               <a:rPr sz="1280" b="0" u="none">
@@ -6567,7 +6567,7 @@
                 <a:cs typeface="Arial"/>
                 <a:hlinkClick xmlns:r="http://schemas.openxmlformats.org/officeDocument/2006/relationships" r:id="R9922704af3ca4538"/>
               </a:rPr>
-              <a:t>S6 worker runbook ↗</a:t>
+              <a:t>S6 worker runbook »</a:t>
             </a:r>
             <a:endParaRPr sz="1280" b="0" u="none">
               <a:solidFill>
@@ -11007,7 +11007,7 @@
                 <a:cs typeface="Arial"/>
                 <a:hlinkClick xmlns:r="http://schemas.openxmlformats.org/officeDocument/2006/relationships" r:id="R1fb809a102f341f9"/>
               </a:rPr>
-              <a:t>a626556e…55657 ↗</a:t>
+              <a:t>a626556e…55657 »</a:t>
             </a:r>
             <a:endParaRPr sz="980" b="0" u="none">
               <a:solidFill>
@@ -11142,7 +11142,7 @@
                 <a:cs typeface="Arial"/>
                 <a:hlinkClick xmlns:r="http://schemas.openxmlformats.org/officeDocument/2006/relationships" r:id="R4d7e43b2c1a54e8e"/>
               </a:rPr>
-              <a:t>c740cf0e…822ad ↗</a:t>
+              <a:t>c740cf0e…822ad »</a:t>
             </a:r>
             <a:endParaRPr sz="980" b="0" u="none">
               <a:solidFill>
@@ -11277,7 +11277,7 @@
                 <a:cs typeface="Arial"/>
                 <a:hlinkClick xmlns:r="http://schemas.openxmlformats.org/officeDocument/2006/relationships" r:id="R1acadc2743294224"/>
               </a:rPr>
-              <a:t>a0c24a10…b13b6 ↗</a:t>
+              <a:t>a0c24a10…b13b6 »</a:t>
             </a:r>
             <a:endParaRPr sz="980" b="0" u="none">
               <a:solidFill>
@@ -11412,7 +11412,7 @@
                 <a:cs typeface="Arial"/>
                 <a:hlinkClick xmlns:r="http://schemas.openxmlformats.org/officeDocument/2006/relationships" r:id="Rf4cdc9222ee54d8b"/>
               </a:rPr>
-              <a:t>8d859033…840c2 ↗</a:t>
+              <a:t>8d859033…840c2 »</a:t>
             </a:r>
             <a:endParaRPr sz="980" b="0" u="none">
               <a:solidFill>
@@ -15201,7 +15201,7 @@
                 <a:cs typeface="Arial"/>
                 <a:hlinkClick xmlns:r="http://schemas.openxmlformats.org/officeDocument/2006/relationships" r:id="R573d55518fa44920"/>
               </a:rPr>
-              <a:t>Open report and manifests ↗</a:t>
+              <a:t>Open report and manifests »</a:t>
             </a:r>
             <a:endParaRPr sz="1200" b="0" u="none">
               <a:solidFill>
@@ -16314,7 +16314,7 @@
                 <a:cs typeface="Arial"/>
                 <a:hlinkClick xmlns:r="http://schemas.openxmlformats.org/officeDocument/2006/relationships" r:id="Rd6da856e1f9e4f32"/>
               </a:rPr>
-              <a:t>Inspect the S6 coverage matrix ↗</a:t>
+              <a:t>Inspect the S6 coverage matrix »</a:t>
             </a:r>
             <a:endParaRPr sz="1200" b="0" u="none">
               <a:solidFill>
@@ -17640,7 +17640,7 @@
                 <a:cs typeface="Arial"/>
                 <a:hlinkClick xmlns:r="http://schemas.openxmlformats.org/officeDocument/2006/relationships" r:id="R008692ed749d4a85"/>
               </a:rPr>
-              <a:t>Precompile findings ↗</a:t>
+              <a:t>Precompile findings »</a:t>
             </a:r>
             <a:r>
               <a:rPr sz="1200" b="0" u="none">
@@ -17663,7 +17663,7 @@
                 <a:cs typeface="Arial"/>
                 <a:hlinkClick xmlns:r="http://schemas.openxmlformats.org/officeDocument/2006/relationships" r:id="Rc3371b947de14928"/>
               </a:rPr>
-              <a:t>Attestcoin integration ↗</a:t>
+              <a:t>Attestcoin integration »</a:t>
             </a:r>
             <a:endParaRPr sz="1200" b="0" u="none">
               <a:solidFill>

</xml_diff>